<commit_message>
docs: adopt updated animated deck foundation
</commit_message>
<xml_diff>
--- a/github-stacked-prs-animated-base.pptx
+++ b/github-stacked-prs-animated-base.pptx
@@ -5,12 +5,13 @@
     <p:sldMasterId id="2147483648" r:id="rId1"/>
   </p:sldMasterIdLst>
   <p:notesMasterIdLst>
-    <p:notesMasterId r:id="rId5"/>
+    <p:notesMasterId r:id="rId6"/>
   </p:notesMasterIdLst>
   <p:sldIdLst>
-    <p:sldId id="256" r:id="rId2"/>
-    <p:sldId id="257" r:id="rId3"/>
-    <p:sldId id="258" r:id="rId4"/>
+    <p:sldId id="259" r:id="rId2"/>
+    <p:sldId id="256" r:id="rId3"/>
+    <p:sldId id="257" r:id="rId4"/>
+    <p:sldId id="258" r:id="rId5"/>
   </p:sldIdLst>
   <p:sldSz cx="9144000" cy="5143500" type="screen16x9"/>
   <p:notesSz cx="5143500" cy="9144000"/>
@@ -307,7 +308,7 @@
           <a:p>
             <a:fld id="{F7021451-1387-4CA6-816F-3879F97B5CBC}" type="slidenum">
               <a:rPr lang="en-US"/>
-              <a:t>1</a:t>
+              <a:t>2</a:t>
             </a:fld>
             <a:endParaRPr lang="en-US"/>
           </a:p>
@@ -394,7 +395,7 @@
           <a:p>
             <a:fld id="{F7021451-1387-4CA6-816F-3879F97B5CBC}" type="slidenum">
               <a:rPr lang="en-US"/>
-              <a:t>2</a:t>
+              <a:t>3</a:t>
             </a:fld>
             <a:endParaRPr lang="en-US"/>
           </a:p>
@@ -481,7 +482,7 @@
           <a:p>
             <a:fld id="{F7021451-1387-4CA6-816F-3879F97B5CBC}" type="slidenum">
               <a:rPr lang="en-US"/>
-              <a:t>3</a:t>
+              <a:t>4</a:t>
             </a:fld>
             <a:endParaRPr lang="en-US"/>
           </a:p>
@@ -845,6 +846,264 @@
         </p:nvSpPr>
         <p:spPr>
           <a:xfrm>
+            <a:off x="482501" y="1396901"/>
+            <a:ext cx="711101" cy="63401"/>
+          </a:xfrm>
+          <a:prstGeom prst="rect">
+            <a:avLst/>
+          </a:prstGeom>
+          <a:solidFill>
+            <a:srgbClr val="2EA043"/>
+          </a:solidFill>
+          <a:ln/>
+        </p:spPr>
+        <p:txBody>
+          <a:bodyPr wrap="square" rtlCol="0" anchor="ctr"/>
+          <a:lstStyle/>
+          <a:p>
+            <a:pPr marL="0" indent="0">
+              <a:buNone/>
+            </a:pPr>
+            <a:endParaRPr lang="en-US" dirty="0"/>
+          </a:p>
+        </p:txBody>
+      </p:sp>
+      <p:sp>
+        <p:nvSpPr>
+          <p:cNvPr id="4" name="Text 2"/>
+          <p:cNvSpPr/>
+          <p:nvPr/>
+        </p:nvSpPr>
+        <p:spPr>
+          <a:xfrm>
+            <a:off x="482501" y="1850827"/>
+            <a:ext cx="7642759" cy="1042392"/>
+          </a:xfrm>
+          <a:prstGeom prst="rect">
+            <a:avLst/>
+          </a:prstGeom>
+          <a:noFill/>
+          <a:ln/>
+        </p:spPr>
+        <p:txBody>
+          <a:bodyPr wrap="square" lIns="0" tIns="0" rIns="0" bIns="0" rtlCol="0" anchor="t"/>
+          <a:lstStyle/>
+          <a:p>
+            <a:pPr marL="0" indent="0" algn="l">
+              <a:lnSpc>
+                <a:spcPts val="4104"/>
+              </a:lnSpc>
+              <a:buNone/>
+            </a:pPr>
+            <a:r>
+              <a:rPr lang="en-US" sz="3800" b="1" dirty="0">
+                <a:solidFill>
+                  <a:srgbClr val="F0F6FC"/>
+                </a:solidFill>
+                <a:latin typeface="Arial" pitchFamily="34" charset="0"/>
+                <a:ea typeface="Arial" pitchFamily="34" charset="-122"/>
+                <a:cs typeface="Arial" pitchFamily="34" charset="-120"/>
+              </a:rPr>
+              <a:t>Getting Started with GitHub Stacked PRs</a:t>
+            </a:r>
+            <a:endParaRPr lang="en-US" sz="3800" dirty="0"/>
+          </a:p>
+        </p:txBody>
+      </p:sp>
+      <p:sp>
+        <p:nvSpPr>
+          <p:cNvPr id="5" name="Text 3"/>
+          <p:cNvSpPr/>
+          <p:nvPr/>
+        </p:nvSpPr>
+        <p:spPr>
+          <a:xfrm>
+            <a:off x="482501" y="3121819"/>
+            <a:ext cx="7383780" cy="561380"/>
+          </a:xfrm>
+          <a:prstGeom prst="rect">
+            <a:avLst/>
+          </a:prstGeom>
+          <a:noFill/>
+          <a:ln/>
+        </p:spPr>
+        <p:txBody>
+          <a:bodyPr wrap="square" lIns="0" tIns="0" rIns="0" bIns="0" rtlCol="0" anchor="t"/>
+          <a:lstStyle/>
+          <a:p>
+            <a:pPr marL="0" indent="0" algn="l">
+              <a:lnSpc>
+                <a:spcPts val="2210"/>
+              </a:lnSpc>
+              <a:spcBef>
+                <a:spcPts val="1800"/>
+              </a:spcBef>
+              <a:buNone/>
+            </a:pPr>
+            <a:r>
+              <a:rPr lang="en-US" sz="1700" dirty="0">
+                <a:solidFill>
+                  <a:srgbClr val="B1BAC4"/>
+                </a:solidFill>
+                <a:latin typeface="Arial" pitchFamily="34" charset="0"/>
+                <a:ea typeface="Arial" pitchFamily="34" charset="-122"/>
+                <a:cs typeface="Arial" pitchFamily="34" charset="-120"/>
+              </a:rPr>
+              <a:t>Break large changes into smaller, dependent pull requests that stay connected and remain independently reviewable.</a:t>
+            </a:r>
+            <a:endParaRPr lang="en-US" sz="1700" dirty="0"/>
+          </a:p>
+        </p:txBody>
+      </p:sp>
+      <p:sp>
+        <p:nvSpPr>
+          <p:cNvPr id="7" name="Shape 5"/>
+          <p:cNvSpPr/>
+          <p:nvPr/>
+        </p:nvSpPr>
+        <p:spPr>
+          <a:xfrm>
+            <a:off x="7479792" y="146304"/>
+            <a:ext cx="1078992" cy="283464"/>
+          </a:xfrm>
+          <a:prstGeom prst="roundRect">
+            <a:avLst>
+              <a:gd name="adj" fmla="val 19355"/>
+            </a:avLst>
+          </a:prstGeom>
+          <a:solidFill>
+            <a:srgbClr val="1A5D2A"/>
+          </a:solidFill>
+          <a:ln w="12700">
+            <a:solidFill>
+              <a:srgbClr val="2EA043"/>
+            </a:solidFill>
+            <a:prstDash val="solid"/>
+          </a:ln>
+        </p:spPr>
+        <p:txBody>
+          <a:bodyPr/>
+          <a:lstStyle/>
+          <a:p>
+            <a:endParaRPr lang="en-US"/>
+          </a:p>
+        </p:txBody>
+      </p:sp>
+      <p:sp>
+        <p:nvSpPr>
+          <p:cNvPr id="8" name="Text 6">
+            <a:hlinkClick r:id="rId2"/>
+          </p:cNvPr>
+          <p:cNvSpPr/>
+          <p:nvPr/>
+        </p:nvSpPr>
+        <p:spPr>
+          <a:xfrm>
+            <a:off x="7479792" y="146304"/>
+            <a:ext cx="1078992" cy="283464"/>
+          </a:xfrm>
+          <a:prstGeom prst="rect">
+            <a:avLst/>
+          </a:prstGeom>
+          <a:noFill/>
+          <a:ln/>
+        </p:spPr>
+        <p:txBody>
+          <a:bodyPr wrap="square" lIns="0" tIns="0" rIns="0" bIns="0" rtlCol="0" anchor="ctr"/>
+          <a:lstStyle/>
+          <a:p>
+            <a:pPr marL="0" indent="0" algn="ctr">
+              <a:buNone/>
+            </a:pPr>
+            <a:r>
+              <a:rPr lang="en-US" sz="1050" b="1" u="sng" dirty="0">
+                <a:solidFill>
+                  <a:srgbClr val="FFFFFF"/>
+                </a:solidFill>
+                <a:latin typeface="Arial" pitchFamily="34" charset="0"/>
+                <a:ea typeface="Arial" pitchFamily="34" charset="-122"/>
+                <a:cs typeface="Arial" pitchFamily="34" charset="-120"/>
+                <a:hlinkClick r:id="rId2">
+                  <a:extLst>
+                    <a:ext uri="{A12FA001-AC4F-418D-AE19-62706E023703}">
+                      <ahyp:hlinkClr xmlns:ahyp="http://schemas.microsoft.com/office/drawing/2018/hyperlinkcolor" val="tx"/>
+                    </a:ext>
+                  </a:extLst>
+                </a:hlinkClick>
+              </a:rPr>
+              <a:t>gh.io/stacks</a:t>
+            </a:r>
+            <a:endParaRPr lang="en-US" sz="1050" dirty="0"/>
+          </a:p>
+        </p:txBody>
+      </p:sp>
+      <p:pic>
+        <p:nvPicPr>
+          <p:cNvPr id="9" name="Image 0" descr="/root/projects/work/gh-stack-demo/slides/github-invertocat.png">
+            <a:hlinkClick r:id="rId3"/>
+          </p:cNvPr>
+          <p:cNvPicPr>
+            <a:picLocks noChangeAspect="1"/>
+          </p:cNvPicPr>
+          <p:nvPr/>
+        </p:nvPicPr>
+        <p:blipFill>
+          <a:blip r:embed="rId4"/>
+          <a:stretch>
+            <a:fillRect/>
+          </a:stretch>
+        </p:blipFill>
+        <p:spPr>
+          <a:xfrm>
+            <a:off x="8668512" y="137160"/>
+            <a:ext cx="301752" cy="301752"/>
+          </a:xfrm>
+          <a:prstGeom prst="rect">
+            <a:avLst/>
+          </a:prstGeom>
+        </p:spPr>
+      </p:pic>
+    </p:spTree>
+  </p:cSld>
+  <p:clrMapOvr>
+    <a:masterClrMapping/>
+  </p:clrMapOvr>
+</p:sld>
+</file>
+
+<file path=ppt/slides/slide2.xml><?xml version="1.0" encoding="utf-8"?>
+<p:sld xmlns:a="http://schemas.openxmlformats.org/drawingml/2006/main" xmlns:r="http://schemas.openxmlformats.org/officeDocument/2006/relationships" xmlns:p="http://schemas.openxmlformats.org/presentationml/2006/main">
+  <p:cSld name="Slide 1">
+    <p:bg>
+      <p:bgPr>
+        <a:solidFill>
+          <a:srgbClr val="0D1117"/>
+        </a:solidFill>
+        <a:effectLst/>
+      </p:bgPr>
+    </p:bg>
+    <p:spTree>
+      <p:nvGrpSpPr>
+        <p:cNvPr id="1" name=""/>
+        <p:cNvGrpSpPr/>
+        <p:nvPr/>
+      </p:nvGrpSpPr>
+      <p:grpSpPr>
+        <a:xfrm>
+          <a:off x="0" y="0"/>
+          <a:ext cx="0" cy="0"/>
+          <a:chOff x="0" y="0"/>
+          <a:chExt cx="0" cy="0"/>
+        </a:xfrm>
+      </p:grpSpPr>
+      <p:sp>
+        <p:nvSpPr>
+          <p:cNvPr id="2" name="Text 0"/>
+          <p:cNvSpPr/>
+          <p:nvPr/>
+        </p:nvSpPr>
+        <p:spPr>
+          <a:xfrm>
             <a:off x="482501" y="381000"/>
             <a:ext cx="8342578" cy="152400"/>
           </a:xfrm>
@@ -2136,7 +2395,7 @@
 </p:sld>
 </file>
 
-<file path=ppt/slides/slide2.xml><?xml version="1.0" encoding="utf-8"?>
+<file path=ppt/slides/slide3.xml><?xml version="1.0" encoding="utf-8"?>
 <p:sld xmlns:a="http://schemas.openxmlformats.org/drawingml/2006/main" xmlns:r="http://schemas.openxmlformats.org/officeDocument/2006/relationships" xmlns:p="http://schemas.openxmlformats.org/presentationml/2006/main">
   <p:cSld name="Slide 2">
     <p:bg>
@@ -4683,7 +4942,7 @@
 </p:sld>
 </file>
 
-<file path=ppt/slides/slide3.xml><?xml version="1.0" encoding="utf-8"?>
+<file path=ppt/slides/slide4.xml><?xml version="1.0" encoding="utf-8"?>
 <p:sld xmlns:a="http://schemas.openxmlformats.org/drawingml/2006/main" xmlns:r="http://schemas.openxmlformats.org/officeDocument/2006/relationships" xmlns:p="http://schemas.openxmlformats.org/presentationml/2006/main">
   <p:cSld name="Slide 3">
     <p:bg>

</xml_diff>